<commit_message>
Re-save template (no content change)
Byte-level re-serialization only from re-running fix-text-overflow.js
— verified identical normAutofit coverage on every slide before and
after.

Co-Authored-By: Claude Sonnet 5 <noreply@anthropic.com>
</commit_message>
<xml_diff>
--- a/temp2.pptx
+++ b/temp2.pptx
@@ -20188,14 +20188,14 @@
           <p:nvPr>
             <p:extLst>
               <p:ext uri="{D42A27DB-BD31-4B8C-83A1-F6EECF244321}">
-                <p14:modId xmlns:p14="http://schemas.microsoft.com/office/powerpoint/2010/main" val="2709128162"/>
+                <p14:modId xmlns:p14="http://schemas.microsoft.com/office/powerpoint/2010/main" val="4134917322"/>
               </p:ext>
             </p:extLst>
           </p:nvPr>
         </p:nvGraphicFramePr>
         <p:xfrm>
-          <a:off x="501648" y="2916387"/>
-          <a:ext cx="11163826" cy="2488720"/>
+          <a:off x="501647" y="2916387"/>
+          <a:ext cx="11163820" cy="2360000"/>
         </p:xfrm>
         <a:graphic>
           <a:graphicData uri="http://schemas.openxmlformats.org/drawingml/2006/table">
@@ -20204,70 +20204,63 @@
                 <a:tableStyleId>{5C22544A-7EE6-4342-B048-85BDC9FD1C3A}</a:tableStyleId>
               </a:tblPr>
               <a:tblGrid>
-                <a:gridCol w="1947182">
+                <a:gridCol w="2174774">
                   <a:extLst>
                     <a:ext uri="{9D8B030D-6E8A-4147-A177-3AD203B41FA5}">
                       <a16:colId xmlns:a16="http://schemas.microsoft.com/office/drawing/2014/main" val="20000"/>
                     </a:ext>
                   </a:extLst>
                 </a:gridCol>
-                <a:gridCol w="1168308">
+                <a:gridCol w="1304863">
                   <a:extLst>
                     <a:ext uri="{9D8B030D-6E8A-4147-A177-3AD203B41FA5}">
                       <a16:colId xmlns:a16="http://schemas.microsoft.com/office/drawing/2014/main" val="2650012367"/>
                     </a:ext>
                   </a:extLst>
                 </a:gridCol>
-                <a:gridCol w="1168308">
-                  <a:extLst>
-                    <a:ext uri="{9D8B030D-6E8A-4147-A177-3AD203B41FA5}">
-                      <a16:colId xmlns:a16="http://schemas.microsoft.com/office/drawing/2014/main" val="20001"/>
-                    </a:ext>
-                  </a:extLst>
-                </a:gridCol>
-                <a:gridCol w="1038494">
+                <a:gridCol w="1159876">
                   <a:extLst>
                     <a:ext uri="{9D8B030D-6E8A-4147-A177-3AD203B41FA5}">
                       <a16:colId xmlns:a16="http://schemas.microsoft.com/office/drawing/2014/main" val="20003"/>
                     </a:ext>
                   </a:extLst>
                 </a:gridCol>
-                <a:gridCol w="1038494">
+                <a:gridCol w="1159876">
                   <a:extLst>
                     <a:ext uri="{9D8B030D-6E8A-4147-A177-3AD203B41FA5}">
                       <a16:colId xmlns:a16="http://schemas.microsoft.com/office/drawing/2014/main" val="3720477358"/>
                     </a:ext>
                   </a:extLst>
                 </a:gridCol>
-                <a:gridCol w="1038494">
+                <a:gridCol w="1159876">
                   <a:extLst>
                     <a:ext uri="{9D8B030D-6E8A-4147-A177-3AD203B41FA5}">
                       <a16:colId xmlns:a16="http://schemas.microsoft.com/office/drawing/2014/main" val="20005"/>
                     </a:ext>
                   </a:extLst>
                 </a:gridCol>
-                <a:gridCol w="1038494">
+                <a:gridCol w="1159876">
                   <a:extLst>
                     <a:ext uri="{9D8B030D-6E8A-4147-A177-3AD203B41FA5}">
                       <a16:colId xmlns:a16="http://schemas.microsoft.com/office/drawing/2014/main" val="20006"/>
                     </a:ext>
                   </a:extLst>
                 </a:gridCol>
-                <a:gridCol w="908684">
+                <a:gridCol w="1014893">
                   <a:extLst>
                     <a:ext uri="{9D8B030D-6E8A-4147-A177-3AD203B41FA5}">
                       <a16:colId xmlns:a16="http://schemas.microsoft.com/office/drawing/2014/main" val="20007"/>
                     </a:ext>
                   </a:extLst>
                 </a:gridCol>
-                <a:gridCol w="908684">
+                <a:gridCol w="1014893">
                   <a:extLst>
                     <a:ext uri="{9D8B030D-6E8A-4147-A177-3AD203B41FA5}">
                       <a16:colId xmlns:a16="http://schemas.microsoft.com/office/drawing/2014/main" val="3191463391"/>
                     </a:ext>
                   </a:extLst>
                 </a:gridCol>
-                <a:gridCol w="908684">
+                <a:gridCol w="1014893">
                   <a:extLst>
                     <a:ext uri="{9D8B030D-6E8A-4147-A177-3AD203B41FA5}">
                       <a16:colId xmlns:a16="http://schemas.microsoft.com/office/drawing/2014/main" val="20008"/>
@@ -20276,7 +20269,7 @@
                 </a:gridCol>
               </a:tblGrid>
               <a:tr h="280000">
-                <a:tc gridSpan="10">
+                <a:tc gridSpan="9">
                   <a:txBody>
                     <a:bodyPr/>
                     <a:lstStyle/>
@@ -20324,16 +20317,6 @@
                     <a:bodyPr/>
                     <a:lstStyle/>
                     <a:p>
-                      <a:endParaRPr/>
-                    </a:p>
-                  </a:txBody>
-                  <a:tcPr/>
-                </a:tc>
-                <a:tc hMerge="1">
-                  <a:txBody>
-                    <a:bodyPr/>
-                    <a:lstStyle/>
-                    <a:p>
                       <a:endParaRPr lang="en-US"/>
                     </a:p>
                   </a:txBody>
@@ -20433,29 +20416,6 @@
                           <a:latin typeface="+mn-lt"/>
                         </a:rPr>
                         <a:t>Planned TCs</a:t>
-                      </a:r>
-                    </a:p>
-                  </a:txBody>
-                  <a:tcPr anchor="ctr">
-                    <a:solidFill>
-                      <a:srgbClr val="F2F2F2"/>
-                    </a:solidFill>
-                  </a:tcPr>
-                </a:tc>
-                <a:tc>
-                  <a:txBody>
-                    <a:bodyPr/>
-                    <a:lstStyle/>
-                    <a:p>
-                      <a:pPr algn="ctr"/>
-                      <a:r>
-                        <a:rPr lang="en-US" sz="1000" b="1">
-                          <a:solidFill>
-                            <a:srgbClr val="313131"/>
-                          </a:solidFill>
-                          <a:latin typeface="+mn-lt"/>
-                        </a:rPr>
-                        <a:t>Target Completion Date</a:t>
                       </a:r>
                     </a:p>
                   </a:txBody>
@@ -20667,29 +20627,6 @@
                         </a:rPr>
                         <a:t>{{NETMTTC}}</a:t>
                       </a:r>
-                    </a:p>
-                  </a:txBody>
-                  <a:tcPr anchor="ctr"/>
-                </a:tc>
-                <a:tc>
-                  <a:txBody>
-                    <a:bodyPr/>
-                    <a:lstStyle/>
-                    <a:p>
-                      <a:pPr lvl="0" algn="ctr">
-                        <a:buNone/>
-                      </a:pPr>
-                      <a:r>
-                        <a:rPr lang="en-US" sz="1000" b="0" i="0" u="none" strike="noStrike" noProof="0">
-                          <a:latin typeface="+mn-lt"/>
-                          <a:ea typeface="Calibri"/>
-                          <a:cs typeface="Calibri"/>
-                        </a:rPr>
-                        <a:t>10/15/2026</a:t>
-                      </a:r>
-                      <a:endParaRPr lang="en-US" sz="1000">
-                        <a:latin typeface="+mn-lt"/>
-                      </a:endParaRPr>
                     </a:p>
                   </a:txBody>
                   <a:tcPr anchor="ctr"/>
@@ -20811,18 +20748,40 @@
                   </a:txBody>
                   <a:tcPr anchor="ctr"/>
                 </a:tc>
-                <a:tc>
-                  <a:txBody>
-                    <a:bodyPr/>
-                    <a:lstStyle/>
-                    <a:p>
-                      <a:pPr algn="ctr"/>
+                <a:tc rowSpan="4">
+                  <a:txBody>
+                    <a:bodyPr/>
+                    <a:lstStyle/>
+                    <a:p>
+                      <a:pPr marL="0" marR="0" lvl="0" indent="0" algn="ctr" defTabSz="914400" rtl="0" eaLnBrk="1" fontAlgn="auto" latinLnBrk="0" hangingPunct="1">
+                        <a:lnSpc>
+                          <a:spcPct val="100000"/>
+                        </a:lnSpc>
+                        <a:spcBef>
+                          <a:spcPts val="0"/>
+                        </a:spcBef>
+                        <a:spcAft>
+                          <a:spcPts val="0"/>
+                        </a:spcAft>
+                        <a:buClrTx/>
+                        <a:buSzTx/>
+                        <a:buFontTx/>
+                        <a:buNone/>
+                        <a:tabLst/>
+                        <a:defRPr/>
+                      </a:pPr>
                       <a:r>
-                        <a:rPr lang="en-US" sz="1000">
+                        <a:rPr lang="en-US" sz="1000" kern="1200" dirty="0">
+                          <a:solidFill>
+                            <a:schemeClr val="dk1"/>
+                          </a:solidFill>
                           <a:latin typeface="+mn-lt"/>
+                          <a:ea typeface="+mn-ea"/>
+                          <a:cs typeface="+mn-cs"/>
                         </a:rPr>
-                        <a:t>{{NETMB}}</a:t>
+                        <a:t>{{PDMB}}</a:t>
                       </a:r>
+                      <a:endParaRPr lang="en-US" sz="1000" dirty="0"/>
                     </a:p>
                   </a:txBody>
                   <a:tcPr anchor="ctr"/>
@@ -20865,22 +20824,6 @@
                           <a:latin typeface="+mn-lt"/>
                         </a:rPr>
                         <a:t>{{RATMTTC}}</a:t>
-                      </a:r>
-                    </a:p>
-                  </a:txBody>
-                  <a:tcPr anchor="ctr"/>
-                </a:tc>
-                <a:tc>
-                  <a:txBody>
-                    <a:bodyPr/>
-                    <a:lstStyle/>
-                    <a:p>
-                      <a:pPr algn="ctr"/>
-                      <a:r>
-                        <a:rPr lang="en-US" sz="1000">
-                          <a:latin typeface="+mn-lt"/>
-                        </a:rPr>
-                        <a:t>10/15/2026</a:t>
                       </a:r>
                     </a:p>
                   </a:txBody>
@@ -21003,18 +20946,12 @@
                   </a:txBody>
                   <a:tcPr anchor="ctr"/>
                 </a:tc>
-                <a:tc>
-                  <a:txBody>
-                    <a:bodyPr/>
-                    <a:lstStyle/>
-                    <a:p>
-                      <a:pPr algn="ctr"/>
-                      <a:r>
-                        <a:rPr lang="en-US" sz="1000">
-                          <a:latin typeface="+mn-lt"/>
-                        </a:rPr>
-                        <a:t>{{RATMB}}</a:t>
-                      </a:r>
+                <a:tc vMerge="1">
+                  <a:txBody>
+                    <a:bodyPr/>
+                    <a:lstStyle/>
+                    <a:p>
+                      <a:endParaRPr/>
                     </a:p>
                   </a:txBody>
                   <a:tcPr anchor="ctr"/>
@@ -21058,29 +20995,6 @@
                         </a:rPr>
                         <a:t>{{BNFRTTC}}</a:t>
                       </a:r>
-                    </a:p>
-                  </a:txBody>
-                  <a:tcPr anchor="ctr"/>
-                </a:tc>
-                <a:tc>
-                  <a:txBody>
-                    <a:bodyPr/>
-                    <a:lstStyle/>
-                    <a:p>
-                      <a:pPr lvl="0" algn="ctr">
-                        <a:buNone/>
-                      </a:pPr>
-                      <a:r>
-                        <a:rPr lang="en-US" sz="1000" b="0" i="0" u="none" strike="noStrike" noProof="0" dirty="0">
-                          <a:latin typeface="+mn-lt"/>
-                          <a:ea typeface="Calibri"/>
-                          <a:cs typeface="Calibri"/>
-                        </a:rPr>
-                        <a:t>10/15/2026</a:t>
-                      </a:r>
-                      <a:endParaRPr lang="en-US" sz="1000" dirty="0">
-                        <a:latin typeface="+mn-lt"/>
-                      </a:endParaRPr>
                     </a:p>
                   </a:txBody>
                   <a:tcPr anchor="ctr"/>
@@ -21202,18 +21116,12 @@
                   </a:txBody>
                   <a:tcPr anchor="ctr"/>
                 </a:tc>
-                <a:tc>
-                  <a:txBody>
-                    <a:bodyPr/>
-                    <a:lstStyle/>
-                    <a:p>
-                      <a:pPr algn="ctr"/>
-                      <a:r>
-                        <a:rPr lang="en-US" sz="1000" dirty="0">
-                          <a:latin typeface="+mn-lt"/>
-                        </a:rPr>
-                        <a:t>{{BNFRB}}</a:t>
-                      </a:r>
+                <a:tc vMerge="1">
+                  <a:txBody>
+                    <a:bodyPr/>
+                    <a:lstStyle/>
+                    <a:p>
+                      <a:endParaRPr/>
                     </a:p>
                   </a:txBody>
                   <a:tcPr anchor="ctr"/>
@@ -21257,29 +21165,6 @@
                         </a:rPr>
                         <a:t>{{PLNCTTC}}</a:t>
                       </a:r>
-                    </a:p>
-                  </a:txBody>
-                  <a:tcPr anchor="ctr"/>
-                </a:tc>
-                <a:tc>
-                  <a:txBody>
-                    <a:bodyPr/>
-                    <a:lstStyle/>
-                    <a:p>
-                      <a:pPr lvl="0" algn="ctr">
-                        <a:buNone/>
-                      </a:pPr>
-                      <a:r>
-                        <a:rPr lang="en-US" sz="1000" b="0" i="0" u="none" strike="noStrike" noProof="0" dirty="0">
-                          <a:latin typeface="+mn-lt"/>
-                          <a:ea typeface="Calibri"/>
-                          <a:cs typeface="Calibri"/>
-                        </a:rPr>
-                        <a:t>10/15/2026</a:t>
-                      </a:r>
-                      <a:endParaRPr lang="en-US" sz="1000" dirty="0">
-                        <a:latin typeface="+mn-lt"/>
-                      </a:endParaRPr>
                     </a:p>
                   </a:txBody>
                   <a:tcPr anchor="ctr"/>
@@ -21401,18 +21286,12 @@
                   </a:txBody>
                   <a:tcPr anchor="ctr"/>
                 </a:tc>
-                <a:tc>
-                  <a:txBody>
-                    <a:bodyPr/>
-                    <a:lstStyle/>
-                    <a:p>
-                      <a:pPr algn="ctr"/>
-                      <a:r>
-                        <a:rPr lang="en-US" sz="1000" dirty="0">
-                          <a:latin typeface="+mn-lt"/>
-                        </a:rPr>
-                        <a:t>{{PLNCB}}</a:t>
-                      </a:r>
+                <a:tc vMerge="1">
+                  <a:txBody>
+                    <a:bodyPr/>
+                    <a:lstStyle/>
+                    <a:p>
+                      <a:endParaRPr dirty="0"/>
                     </a:p>
                   </a:txBody>
                   <a:tcPr anchor="ctr"/>
@@ -21465,33 +21344,6 @@
                           <a:cs typeface="+mn-cs"/>
                         </a:rPr>
                         <a:t>{{PDMTTC}}</a:t>
-                      </a:r>
-                    </a:p>
-                  </a:txBody>
-                  <a:tcPr anchor="ctr">
-                    <a:solidFill>
-                      <a:srgbClr val="2C9B9A"/>
-                    </a:solidFill>
-                  </a:tcPr>
-                </a:tc>
-                <a:tc>
-                  <a:txBody>
-                    <a:bodyPr/>
-                    <a:lstStyle/>
-                    <a:p>
-                      <a:pPr marL="0" lvl="0" algn="ctr" defTabSz="914400" rtl="0" eaLnBrk="1" latinLnBrk="0" hangingPunct="1">
-                        <a:buNone/>
-                      </a:pPr>
-                      <a:r>
-                        <a:rPr lang="en-US" sz="1000" b="1" kern="1200" dirty="0">
-                          <a:solidFill>
-                            <a:srgbClr val="FFFFFF"/>
-                          </a:solidFill>
-                          <a:latin typeface="+mn-lt"/>
-                          <a:ea typeface="+mn-ea"/>
-                          <a:cs typeface="+mn-cs"/>
-                        </a:rPr>
-                        <a:t>--</a:t>
                       </a:r>
                     </a:p>
                   </a:txBody>
@@ -23009,14 +22861,14 @@
           <p:nvPr>
             <p:extLst>
               <p:ext uri="{D42A27DB-BD31-4B8C-83A1-F6EECF244321}">
-                <p14:modId xmlns:p14="http://schemas.microsoft.com/office/powerpoint/2010/main" val="2522658151"/>
+                <p14:modId xmlns:p14="http://schemas.microsoft.com/office/powerpoint/2010/main" val="4262869009"/>
               </p:ext>
             </p:extLst>
           </p:nvPr>
         </p:nvGraphicFramePr>
         <p:xfrm>
-          <a:off x="501647" y="2916387"/>
-          <a:ext cx="11163817" cy="1696240"/>
+          <a:off x="501646" y="2916387"/>
+          <a:ext cx="11163821" cy="1680000"/>
         </p:xfrm>
         <a:graphic>
           <a:graphicData uri="http://schemas.openxmlformats.org/drawingml/2006/table">
@@ -23025,70 +22877,63 @@
                 <a:tableStyleId>{5C22544A-7EE6-4342-B048-85BDC9FD1C3A}</a:tableStyleId>
               </a:tblPr>
               <a:tblGrid>
-                <a:gridCol w="1947182">
+                <a:gridCol w="2174775">
                   <a:extLst>
                     <a:ext uri="{9D8B030D-6E8A-4147-A177-3AD203B41FA5}">
                       <a16:colId xmlns:a16="http://schemas.microsoft.com/office/drawing/2014/main" val="20000"/>
                     </a:ext>
                   </a:extLst>
                 </a:gridCol>
-                <a:gridCol w="1168307">
+                <a:gridCol w="1304863">
                   <a:extLst>
                     <a:ext uri="{9D8B030D-6E8A-4147-A177-3AD203B41FA5}">
                       <a16:colId xmlns:a16="http://schemas.microsoft.com/office/drawing/2014/main" val="2650012367"/>
                     </a:ext>
                   </a:extLst>
                 </a:gridCol>
-                <a:gridCol w="1168307">
-                  <a:extLst>
-                    <a:ext uri="{9D8B030D-6E8A-4147-A177-3AD203B41FA5}">
-                      <a16:colId xmlns:a16="http://schemas.microsoft.com/office/drawing/2014/main" val="20001"/>
-                    </a:ext>
-                  </a:extLst>
-                </a:gridCol>
-                <a:gridCol w="1038493">
+                <a:gridCol w="1159876">
                   <a:extLst>
                     <a:ext uri="{9D8B030D-6E8A-4147-A177-3AD203B41FA5}">
                       <a16:colId xmlns:a16="http://schemas.microsoft.com/office/drawing/2014/main" val="20003"/>
                     </a:ext>
                   </a:extLst>
                 </a:gridCol>
-                <a:gridCol w="1038493">
+                <a:gridCol w="1159876">
                   <a:extLst>
                     <a:ext uri="{9D8B030D-6E8A-4147-A177-3AD203B41FA5}">
                       <a16:colId xmlns:a16="http://schemas.microsoft.com/office/drawing/2014/main" val="20005"/>
                     </a:ext>
                   </a:extLst>
                 </a:gridCol>
-                <a:gridCol w="1038493">
+                <a:gridCol w="1159876">
                   <a:extLst>
                     <a:ext uri="{9D8B030D-6E8A-4147-A177-3AD203B41FA5}">
                       <a16:colId xmlns:a16="http://schemas.microsoft.com/office/drawing/2014/main" val="3383328722"/>
                     </a:ext>
                   </a:extLst>
                 </a:gridCol>
-                <a:gridCol w="1038493">
+                <a:gridCol w="1159876">
                   <a:extLst>
                     <a:ext uri="{9D8B030D-6E8A-4147-A177-3AD203B41FA5}">
                       <a16:colId xmlns:a16="http://schemas.microsoft.com/office/drawing/2014/main" val="20006"/>
                     </a:ext>
                   </a:extLst>
                 </a:gridCol>
-                <a:gridCol w="908683">
+                <a:gridCol w="1014893">
                   <a:extLst>
                     <a:ext uri="{9D8B030D-6E8A-4147-A177-3AD203B41FA5}">
                       <a16:colId xmlns:a16="http://schemas.microsoft.com/office/drawing/2014/main" val="3191463391"/>
                     </a:ext>
                   </a:extLst>
                 </a:gridCol>
-                <a:gridCol w="908683">
+                <a:gridCol w="1014893">
                   <a:extLst>
                     <a:ext uri="{9D8B030D-6E8A-4147-A177-3AD203B41FA5}">
                       <a16:colId xmlns:a16="http://schemas.microsoft.com/office/drawing/2014/main" val="3705187464"/>
                     </a:ext>
                   </a:extLst>
                 </a:gridCol>
-                <a:gridCol w="908683">
+                <a:gridCol w="1014893">
                   <a:extLst>
                     <a:ext uri="{9D8B030D-6E8A-4147-A177-3AD203B41FA5}">
                       <a16:colId xmlns:a16="http://schemas.microsoft.com/office/drawing/2014/main" val="20008"/>
@@ -23097,7 +22942,7 @@
                 </a:gridCol>
               </a:tblGrid>
               <a:tr h="280000">
-                <a:tc gridSpan="10">
+                <a:tc gridSpan="9">
                   <a:txBody>
                     <a:bodyPr/>
                     <a:lstStyle/>
@@ -23155,16 +23000,6 @@
                     <a:bodyPr/>
                     <a:lstStyle/>
                     <a:p>
-                      <a:endParaRPr/>
-                    </a:p>
-                  </a:txBody>
-                  <a:tcPr/>
-                </a:tc>
-                <a:tc hMerge="1">
-                  <a:txBody>
-                    <a:bodyPr/>
-                    <a:lstStyle/>
-                    <a:p>
                       <a:endParaRPr lang="en-US"/>
                     </a:p>
                   </a:txBody>
@@ -23254,29 +23089,6 @@
                           <a:latin typeface="+mn-lt"/>
                         </a:rPr>
                         <a:t>Planned TCs</a:t>
-                      </a:r>
-                    </a:p>
-                  </a:txBody>
-                  <a:tcPr anchor="ctr">
-                    <a:solidFill>
-                      <a:srgbClr val="F2F2F2"/>
-                    </a:solidFill>
-                  </a:tcPr>
-                </a:tc>
-                <a:tc>
-                  <a:txBody>
-                    <a:bodyPr/>
-                    <a:lstStyle/>
-                    <a:p>
-                      <a:pPr algn="ctr"/>
-                      <a:r>
-                        <a:rPr lang="en-US" sz="1000" b="1">
-                          <a:solidFill>
-                            <a:srgbClr val="313131"/>
-                          </a:solidFill>
-                          <a:latin typeface="+mn-lt"/>
-                        </a:rPr>
-                        <a:t>Target Completion Date</a:t>
                       </a:r>
                     </a:p>
                   </a:txBody>
@@ -23532,38 +23344,6 @@
                         <a:rPr lang="en-US" sz="1000" dirty="0">
                           <a:latin typeface="+mn-lt"/>
                         </a:rPr>
-                        <a:t>10/15/2026</a:t>
-                      </a:r>
-                    </a:p>
-                  </a:txBody>
-                  <a:tcPr anchor="ctr"/>
-                </a:tc>
-                <a:tc>
-                  <a:txBody>
-                    <a:bodyPr/>
-                    <a:lstStyle/>
-                    <a:p>
-                      <a:pPr marL="0" marR="0" lvl="0" indent="0" algn="ctr" defTabSz="914400" rtl="0" eaLnBrk="1" fontAlgn="auto" latinLnBrk="0" hangingPunct="1">
-                        <a:lnSpc>
-                          <a:spcPct val="100000"/>
-                        </a:lnSpc>
-                        <a:spcBef>
-                          <a:spcPts val="0"/>
-                        </a:spcBef>
-                        <a:spcAft>
-                          <a:spcPts val="0"/>
-                        </a:spcAft>
-                        <a:buClrTx/>
-                        <a:buSzTx/>
-                        <a:buFontTx/>
-                        <a:buNone/>
-                        <a:tabLst/>
-                        <a:defRPr/>
-                      </a:pPr>
-                      <a:r>
-                        <a:rPr lang="en-US" sz="1000" dirty="0">
-                          <a:latin typeface="+mn-lt"/>
-                        </a:rPr>
                         <a:t>{{FILPETC}}</a:t>
                       </a:r>
                     </a:p>
@@ -23666,7 +23446,7 @@
                   </a:txBody>
                   <a:tcPr anchor="ctr"/>
                 </a:tc>
-                <a:tc>
+                <a:tc rowSpan="2">
                   <a:txBody>
                     <a:bodyPr/>
                     <a:lstStyle/>
@@ -23692,7 +23472,7 @@
                         <a:rPr lang="en-US" sz="1000" dirty="0">
                           <a:latin typeface="+mn-lt"/>
                         </a:rPr>
-                        <a:t>{{FILPB}}</a:t>
+                        <a:t>{{EDIB}}</a:t>
                       </a:r>
                     </a:p>
                   </a:txBody>
@@ -23783,38 +23563,6 @@
                         <a:rPr lang="en-US" sz="1000" dirty="0">
                           <a:latin typeface="+mn-lt"/>
                         </a:rPr>
-                        <a:t>10/15/2026</a:t>
-                      </a:r>
-                    </a:p>
-                  </a:txBody>
-                  <a:tcPr anchor="ctr"/>
-                </a:tc>
-                <a:tc>
-                  <a:txBody>
-                    <a:bodyPr/>
-                    <a:lstStyle/>
-                    <a:p>
-                      <a:pPr marL="0" marR="0" lvl="0" indent="0" algn="ctr" defTabSz="914400" rtl="0" eaLnBrk="1" fontAlgn="auto" latinLnBrk="0" hangingPunct="1">
-                        <a:lnSpc>
-                          <a:spcPct val="100000"/>
-                        </a:lnSpc>
-                        <a:spcBef>
-                          <a:spcPts val="0"/>
-                        </a:spcBef>
-                        <a:spcAft>
-                          <a:spcPts val="0"/>
-                        </a:spcAft>
-                        <a:buClrTx/>
-                        <a:buSzTx/>
-                        <a:buFontTx/>
-                        <a:buNone/>
-                        <a:tabLst/>
-                        <a:defRPr/>
-                      </a:pPr>
-                      <a:r>
-                        <a:rPr lang="en-US" sz="1000" dirty="0">
-                          <a:latin typeface="+mn-lt"/>
-                        </a:rPr>
                         <a:t>{{TPSTETC}}</a:t>
                       </a:r>
                     </a:p>
@@ -23917,34 +23665,12 @@
                   </a:txBody>
                   <a:tcPr anchor="ctr"/>
                 </a:tc>
-                <a:tc>
-                  <a:txBody>
-                    <a:bodyPr/>
-                    <a:lstStyle/>
-                    <a:p>
-                      <a:pPr marL="0" marR="0" lvl="0" indent="0" algn="ctr" defTabSz="914400" rtl="0" eaLnBrk="1" fontAlgn="auto" latinLnBrk="0" hangingPunct="1">
-                        <a:lnSpc>
-                          <a:spcPct val="100000"/>
-                        </a:lnSpc>
-                        <a:spcBef>
-                          <a:spcPts val="0"/>
-                        </a:spcBef>
-                        <a:spcAft>
-                          <a:spcPts val="0"/>
-                        </a:spcAft>
-                        <a:buClrTx/>
-                        <a:buSzTx/>
-                        <a:buFontTx/>
-                        <a:buNone/>
-                        <a:tabLst/>
-                        <a:defRPr/>
-                      </a:pPr>
-                      <a:r>
-                        <a:rPr lang="en-US" sz="1000" dirty="0">
-                          <a:latin typeface="+mn-lt"/>
-                        </a:rPr>
-                        <a:t>{{TPSTB}}</a:t>
-                      </a:r>
+                <a:tc vMerge="1">
+                  <a:txBody>
+                    <a:bodyPr/>
+                    <a:lstStyle/>
+                    <a:p>
+                      <a:endParaRPr dirty="0"/>
                     </a:p>
                   </a:txBody>
                   <a:tcPr anchor="ctr"/>
@@ -24009,33 +23735,6 @@
                           <a:latin typeface="+mn-lt"/>
                         </a:rPr>
                         <a:t>{{EDITTC}}</a:t>
-                      </a:r>
-                    </a:p>
-                  </a:txBody>
-                  <a:tcPr anchor="ctr">
-                    <a:solidFill>
-                      <a:srgbClr val="2C9B9A"/>
-                    </a:solidFill>
-                  </a:tcPr>
-                </a:tc>
-                <a:tc>
-                  <a:txBody>
-                    <a:bodyPr/>
-                    <a:lstStyle/>
-                    <a:p>
-                      <a:pPr lvl="0" algn="ctr">
-                        <a:buNone/>
-                      </a:pPr>
-                      <a:r>
-                        <a:rPr lang="en-US" sz="1000" b="1" kern="1200" dirty="0">
-                          <a:solidFill>
-                            <a:srgbClr val="FFFFFF"/>
-                          </a:solidFill>
-                          <a:latin typeface="+mn-lt"/>
-                          <a:ea typeface="+mn-ea"/>
-                          <a:cs typeface="+mn-cs"/>
-                        </a:rPr>
-                        <a:t>--</a:t>
                       </a:r>
                     </a:p>
                   </a:txBody>
@@ -25529,14 +25228,14 @@
           <p:nvPr>
             <p:extLst>
               <p:ext uri="{D42A27DB-BD31-4B8C-83A1-F6EECF244321}">
-                <p14:modId xmlns:p14="http://schemas.microsoft.com/office/powerpoint/2010/main" val="3585090496"/>
+                <p14:modId xmlns:p14="http://schemas.microsoft.com/office/powerpoint/2010/main" val="550715687"/>
               </p:ext>
             </p:extLst>
           </p:nvPr>
         </p:nvGraphicFramePr>
         <p:xfrm>
           <a:off x="501648" y="2916387"/>
-          <a:ext cx="11163826" cy="1696240"/>
+          <a:ext cx="11163819" cy="1680000"/>
         </p:xfrm>
         <a:graphic>
           <a:graphicData uri="http://schemas.openxmlformats.org/drawingml/2006/table">
@@ -25545,70 +25244,63 @@
                 <a:tableStyleId>{5C22544A-7EE6-4342-B048-85BDC9FD1C3A}</a:tableStyleId>
               </a:tblPr>
               <a:tblGrid>
-                <a:gridCol w="1947182">
+                <a:gridCol w="2174773">
                   <a:extLst>
                     <a:ext uri="{9D8B030D-6E8A-4147-A177-3AD203B41FA5}">
                       <a16:colId xmlns:a16="http://schemas.microsoft.com/office/drawing/2014/main" val="20000"/>
                     </a:ext>
                   </a:extLst>
                 </a:gridCol>
-                <a:gridCol w="1168308">
+                <a:gridCol w="1304863">
                   <a:extLst>
                     <a:ext uri="{9D8B030D-6E8A-4147-A177-3AD203B41FA5}">
                       <a16:colId xmlns:a16="http://schemas.microsoft.com/office/drawing/2014/main" val="2650012367"/>
                     </a:ext>
                   </a:extLst>
                 </a:gridCol>
-                <a:gridCol w="1168308">
-                  <a:extLst>
-                    <a:ext uri="{9D8B030D-6E8A-4147-A177-3AD203B41FA5}">
-                      <a16:colId xmlns:a16="http://schemas.microsoft.com/office/drawing/2014/main" val="20001"/>
-                    </a:ext>
-                  </a:extLst>
-                </a:gridCol>
-                <a:gridCol w="1038494">
+                <a:gridCol w="1159876">
                   <a:extLst>
                     <a:ext uri="{9D8B030D-6E8A-4147-A177-3AD203B41FA5}">
                       <a16:colId xmlns:a16="http://schemas.microsoft.com/office/drawing/2014/main" val="20003"/>
                     </a:ext>
                   </a:extLst>
                 </a:gridCol>
-                <a:gridCol w="1038494">
+                <a:gridCol w="1159876">
                   <a:extLst>
                     <a:ext uri="{9D8B030D-6E8A-4147-A177-3AD203B41FA5}">
                       <a16:colId xmlns:a16="http://schemas.microsoft.com/office/drawing/2014/main" val="2242662145"/>
                     </a:ext>
                   </a:extLst>
                 </a:gridCol>
-                <a:gridCol w="1038494">
+                <a:gridCol w="1159876">
                   <a:extLst>
                     <a:ext uri="{9D8B030D-6E8A-4147-A177-3AD203B41FA5}">
                       <a16:colId xmlns:a16="http://schemas.microsoft.com/office/drawing/2014/main" val="20005"/>
                     </a:ext>
                   </a:extLst>
                 </a:gridCol>
-                <a:gridCol w="1038494">
+                <a:gridCol w="1159876">
                   <a:extLst>
                     <a:ext uri="{9D8B030D-6E8A-4147-A177-3AD203B41FA5}">
                       <a16:colId xmlns:a16="http://schemas.microsoft.com/office/drawing/2014/main" val="20006"/>
                     </a:ext>
                   </a:extLst>
                 </a:gridCol>
-                <a:gridCol w="908684">
+                <a:gridCol w="1014893">
                   <a:extLst>
                     <a:ext uri="{9D8B030D-6E8A-4147-A177-3AD203B41FA5}">
                       <a16:colId xmlns:a16="http://schemas.microsoft.com/office/drawing/2014/main" val="20007"/>
                     </a:ext>
                   </a:extLst>
                 </a:gridCol>
-                <a:gridCol w="908684">
+                <a:gridCol w="1014893">
                   <a:extLst>
                     <a:ext uri="{9D8B030D-6E8A-4147-A177-3AD203B41FA5}">
                       <a16:colId xmlns:a16="http://schemas.microsoft.com/office/drawing/2014/main" val="3191463391"/>
                     </a:ext>
                   </a:extLst>
                 </a:gridCol>
-                <a:gridCol w="908684">
+                <a:gridCol w="1014893">
                   <a:extLst>
                     <a:ext uri="{9D8B030D-6E8A-4147-A177-3AD203B41FA5}">
                       <a16:colId xmlns:a16="http://schemas.microsoft.com/office/drawing/2014/main" val="20008"/>
@@ -25617,7 +25309,7 @@
                 </a:gridCol>
               </a:tblGrid>
               <a:tr h="280000">
-                <a:tc gridSpan="10">
+                <a:tc gridSpan="9">
                   <a:txBody>
                     <a:bodyPr/>
                     <a:lstStyle/>
@@ -25665,16 +25357,6 @@
                     <a:bodyPr/>
                     <a:lstStyle/>
                     <a:p>
-                      <a:endParaRPr/>
-                    </a:p>
-                  </a:txBody>
-                  <a:tcPr/>
-                </a:tc>
-                <a:tc hMerge="1">
-                  <a:txBody>
-                    <a:bodyPr/>
-                    <a:lstStyle/>
-                    <a:p>
                       <a:endParaRPr lang="en-US"/>
                     </a:p>
                   </a:txBody>
@@ -25774,29 +25456,6 @@
                           <a:latin typeface="Calibri"/>
                         </a:rPr>
                         <a:t>Planned TCs</a:t>
-                      </a:r>
-                    </a:p>
-                  </a:txBody>
-                  <a:tcPr anchor="ctr">
-                    <a:solidFill>
-                      <a:srgbClr val="F2F2F2"/>
-                    </a:solidFill>
-                  </a:tcPr>
-                </a:tc>
-                <a:tc>
-                  <a:txBody>
-                    <a:bodyPr/>
-                    <a:lstStyle/>
-                    <a:p>
-                      <a:pPr algn="ctr"/>
-                      <a:r>
-                        <a:rPr lang="en-US" sz="1000" b="1">
-                          <a:solidFill>
-                            <a:srgbClr val="313131"/>
-                          </a:solidFill>
-                          <a:latin typeface="Calibri"/>
-                        </a:rPr>
-                        <a:t>Target Completion Date</a:t>
                       </a:r>
                     </a:p>
                   </a:txBody>
@@ -26031,38 +25690,6 @@
                     <a:bodyPr/>
                     <a:lstStyle/>
                     <a:p>
-                      <a:pPr marL="0" marR="0" lvl="0" indent="0" algn="ctr" defTabSz="914400" rtl="0" eaLnBrk="1" fontAlgn="auto" latinLnBrk="0" hangingPunct="1">
-                        <a:lnSpc>
-                          <a:spcPct val="100000"/>
-                        </a:lnSpc>
-                        <a:spcBef>
-                          <a:spcPts val="0"/>
-                        </a:spcBef>
-                        <a:spcAft>
-                          <a:spcPts val="0"/>
-                        </a:spcAft>
-                        <a:buClrTx/>
-                        <a:buSzTx/>
-                        <a:buFontTx/>
-                        <a:buNone/>
-                        <a:tabLst/>
-                        <a:defRPr/>
-                      </a:pPr>
-                      <a:r>
-                        <a:rPr lang="en-US" sz="1000" dirty="0">
-                          <a:latin typeface="+mn-lt"/>
-                        </a:rPr>
-                        <a:t>10/15/2026</a:t>
-                      </a:r>
-                    </a:p>
-                  </a:txBody>
-                  <a:tcPr anchor="ctr"/>
-                </a:tc>
-                <a:tc>
-                  <a:txBody>
-                    <a:bodyPr/>
-                    <a:lstStyle/>
-                    <a:p>
                       <a:pPr algn="ctr"/>
                       <a:r>
                         <a:rPr lang="en-US" sz="1000" dirty="0">
@@ -26170,7 +25797,7 @@
                   </a:txBody>
                   <a:tcPr anchor="ctr"/>
                 </a:tc>
-                <a:tc>
+                <a:tc rowSpan="2">
                   <a:txBody>
                     <a:bodyPr/>
                     <a:lstStyle/>
@@ -26193,11 +25820,14 @@
                         <a:defRPr/>
                       </a:pPr>
                       <a:r>
-                        <a:rPr lang="en-US" sz="1000" dirty="0">
+                        <a:rPr lang="en-US" sz="1000">
                           <a:latin typeface="+mn-lt"/>
                         </a:rPr>
-                        <a:t>{{COBRB}}</a:t>
+                        <a:t>{{ENRLB}}</a:t>
                       </a:r>
+                      <a:endParaRPr lang="en-US" sz="1000" dirty="0">
+                        <a:latin typeface="+mn-lt"/>
+                      </a:endParaRPr>
                     </a:p>
                   </a:txBody>
                   <a:tcPr anchor="ctr"/>
@@ -26266,38 +25896,6 @@
                     <a:bodyPr/>
                     <a:lstStyle/>
                     <a:p>
-                      <a:pPr marL="0" marR="0" lvl="0" indent="0" algn="ctr" defTabSz="914400" rtl="0" eaLnBrk="1" fontAlgn="auto" latinLnBrk="0" hangingPunct="1">
-                        <a:lnSpc>
-                          <a:spcPct val="100000"/>
-                        </a:lnSpc>
-                        <a:spcBef>
-                          <a:spcPts val="0"/>
-                        </a:spcBef>
-                        <a:spcAft>
-                          <a:spcPts val="0"/>
-                        </a:spcAft>
-                        <a:buClrTx/>
-                        <a:buSzTx/>
-                        <a:buFontTx/>
-                        <a:buNone/>
-                        <a:tabLst/>
-                        <a:defRPr/>
-                      </a:pPr>
-                      <a:r>
-                        <a:rPr lang="en-US" sz="1000" dirty="0">
-                          <a:latin typeface="+mn-lt"/>
-                        </a:rPr>
-                        <a:t>10/15/2026</a:t>
-                      </a:r>
-                    </a:p>
-                  </a:txBody>
-                  <a:tcPr anchor="ctr"/>
-                </a:tc>
-                <a:tc>
-                  <a:txBody>
-                    <a:bodyPr/>
-                    <a:lstStyle/>
-                    <a:p>
                       <a:pPr algn="ctr"/>
                       <a:r>
                         <a:rPr lang="en-US" sz="1000" dirty="0">
@@ -26405,34 +26003,12 @@
                   </a:txBody>
                   <a:tcPr anchor="ctr"/>
                 </a:tc>
-                <a:tc>
-                  <a:txBody>
-                    <a:bodyPr/>
-                    <a:lstStyle/>
-                    <a:p>
-                      <a:pPr marL="0" marR="0" lvl="0" indent="0" algn="ctr" defTabSz="914400" rtl="0" eaLnBrk="1" fontAlgn="auto" latinLnBrk="0" hangingPunct="1">
-                        <a:lnSpc>
-                          <a:spcPct val="100000"/>
-                        </a:lnSpc>
-                        <a:spcBef>
-                          <a:spcPts val="0"/>
-                        </a:spcBef>
-                        <a:spcAft>
-                          <a:spcPts val="0"/>
-                        </a:spcAft>
-                        <a:buClrTx/>
-                        <a:buSzTx/>
-                        <a:buFontTx/>
-                        <a:buNone/>
-                        <a:tabLst/>
-                        <a:defRPr/>
-                      </a:pPr>
-                      <a:r>
-                        <a:rPr lang="en-US" sz="1000" dirty="0">
-                          <a:latin typeface="+mn-lt"/>
-                        </a:rPr>
-                        <a:t>{{OPENB}}</a:t>
-                      </a:r>
+                <a:tc vMerge="1">
+                  <a:txBody>
+                    <a:bodyPr/>
+                    <a:lstStyle/>
+                    <a:p>
+                      <a:endParaRPr dirty="0"/>
                     </a:p>
                   </a:txBody>
                   <a:tcPr anchor="ctr"/>
@@ -26511,36 +26087,9 @@
                     <a:bodyPr/>
                     <a:lstStyle/>
                     <a:p>
-                      <a:pPr lvl="0" algn="ctr">
-                        <a:buNone/>
-                      </a:pPr>
-                      <a:r>
-                        <a:rPr lang="en-US" sz="1000" b="1" kern="1200">
-                          <a:solidFill>
-                            <a:schemeClr val="bg1"/>
-                          </a:solidFill>
-                          <a:latin typeface="+mn-lt"/>
-                          <a:ea typeface="+mn-ea"/>
-                          <a:cs typeface="+mn-cs"/>
-                        </a:rPr>
-                        <a:t>--</a:t>
-                      </a:r>
-                    </a:p>
-                  </a:txBody>
-                  <a:tcPr anchor="ctr">
-                    <a:solidFill>
-                      <a:srgbClr val="2C9B9A"/>
-                    </a:solidFill>
-                  </a:tcPr>
-                </a:tc>
-                <a:tc>
-                  <a:txBody>
-                    <a:bodyPr/>
-                    <a:lstStyle/>
-                    <a:p>
                       <a:pPr algn="ctr"/>
                       <a:r>
-                        <a:rPr lang="en-US" sz="1000" b="1">
+                        <a:rPr lang="en-US" sz="1000" b="1" dirty="0">
                           <a:solidFill>
                             <a:schemeClr val="bg1"/>
                           </a:solidFill>
@@ -27790,6 +27339,15 @@
 </file>
 
 <file path=customXml/item1.xml><?xml version="1.0" encoding="utf-8"?>
+<?mso-contentType ?>
+<FormTemplates xmlns="http://schemas.microsoft.com/sharepoint/v3/contenttype/forms">
+  <Display>DocumentLibraryForm</Display>
+  <Edit>DocumentLibraryForm</Edit>
+  <New>DocumentLibraryForm</New>
+</FormTemplates>
+</file>
+
+<file path=customXml/item2.xml><?xml version="1.0" encoding="utf-8"?>
 <p:properties xmlns:p="http://schemas.microsoft.com/office/2006/metadata/properties" xmlns:xsi="http://www.w3.org/2001/XMLSchema-instance" xmlns:pc="http://schemas.microsoft.com/office/infopath/2007/PartnerControls">
   <documentManagement>
     <lcf76f155ced4ddcb4097134ff3c332f xmlns="81fd36fe-389a-4f3a-9976-bee25438cfd0">
@@ -27799,7 +27357,7 @@
 </p:properties>
 </file>
 
-<file path=customXml/item2.xml><?xml version="1.0" encoding="utf-8"?>
+<file path=customXml/item3.xml><?xml version="1.0" encoding="utf-8"?>
 <ct:contentTypeSchema xmlns:ct="http://schemas.microsoft.com/office/2006/metadata/contentType" xmlns:ma="http://schemas.microsoft.com/office/2006/metadata/properties/metaAttributes" ct:_="" ma:_="" ma:contentTypeName="Document" ma:contentTypeID="0x0101008F4BBC40EB3D414C83651E0F4794DDEF" ma:contentTypeVersion="11" ma:contentTypeDescription="Create a new document." ma:contentTypeScope="" ma:versionID="ac432b7c7a0758597f364c76a27f3563">
   <xsd:schema xmlns:xsd="http://www.w3.org/2001/XMLSchema" xmlns:xs="http://www.w3.org/2001/XMLSchema" xmlns:p="http://schemas.microsoft.com/office/2006/metadata/properties" xmlns:ns2="81fd36fe-389a-4f3a-9976-bee25438cfd0" targetNamespace="http://schemas.microsoft.com/office/2006/metadata/properties" ma:root="true" ma:fieldsID="e71be0df1837d809186b3abb1c1da983" ns2:_="">
     <xsd:import namespace="81fd36fe-389a-4f3a-9976-bee25438cfd0"/>
@@ -27983,16 +27541,15 @@
 </ct:contentTypeSchema>
 </file>
 
-<file path=customXml/item3.xml><?xml version="1.0" encoding="utf-8"?>
-<?mso-contentType ?>
-<FormTemplates xmlns="http://schemas.microsoft.com/sharepoint/v3/contenttype/forms">
-  <Display>DocumentLibraryForm</Display>
-  <Edit>DocumentLibraryForm</Edit>
-  <New>DocumentLibraryForm</New>
-</FormTemplates>
+<file path=customXml/itemProps1.xml><?xml version="1.0" encoding="utf-8"?>
+<ds:datastoreItem xmlns:ds="http://schemas.openxmlformats.org/officeDocument/2006/customXml" ds:itemID="{107376A1-CC42-438F-85FD-93A015D166A9}">
+  <ds:schemaRefs>
+    <ds:schemaRef ds:uri="http://schemas.microsoft.com/sharepoint/v3/contenttype/forms"/>
+  </ds:schemaRefs>
+</ds:datastoreItem>
 </file>
 
-<file path=customXml/itemProps1.xml><?xml version="1.0" encoding="utf-8"?>
+<file path=customXml/itemProps2.xml><?xml version="1.0" encoding="utf-8"?>
 <ds:datastoreItem xmlns:ds="http://schemas.openxmlformats.org/officeDocument/2006/customXml" ds:itemID="{63CA026D-4666-483B-9EA4-E4BAFDF32B68}">
   <ds:schemaRefs>
     <ds:schemaRef ds:uri="http://purl.org/dc/elements/1.1/"/>
@@ -28008,7 +27565,7 @@
 </ds:datastoreItem>
 </file>
 
-<file path=customXml/itemProps2.xml><?xml version="1.0" encoding="utf-8"?>
+<file path=customXml/itemProps3.xml><?xml version="1.0" encoding="utf-8"?>
 <ds:datastoreItem xmlns:ds="http://schemas.openxmlformats.org/officeDocument/2006/customXml" ds:itemID="{725DAFB6-DF8B-4F0D-BE89-1561B3B7E417}">
   <ds:schemaRefs>
     <ds:schemaRef ds:uri="81fd36fe-389a-4f3a-9976-bee25438cfd0"/>
@@ -28026,14 +27583,6 @@
 </ds:datastoreItem>
 </file>
 
-<file path=customXml/itemProps3.xml><?xml version="1.0" encoding="utf-8"?>
-<ds:datastoreItem xmlns:ds="http://schemas.openxmlformats.org/officeDocument/2006/customXml" ds:itemID="{107376A1-CC42-438F-85FD-93A015D166A9}">
-  <ds:schemaRefs>
-    <ds:schemaRef ds:uri="http://schemas.microsoft.com/sharepoint/v3/contenttype/forms"/>
-  </ds:schemaRefs>
-</ds:datastoreItem>
-</file>
-
 <file path=docMetadata/LabelInfo.xml><?xml version="1.0" encoding="utf-8"?>
 <clbl:labelList xmlns:clbl="http://schemas.microsoft.com/office/2020/mipLabelMetadata">
   <clbl:label id="{ea60d57e-af5b-4752-ac57-3e4f28ca11dc}" enabled="1" method="Standard" siteId="{36da45f1-dd2c-4d1f-af13-5abe46b99921}" removed="0"/>

</xml_diff>